<commit_message>
added a web demo and updated ablation to use dropout instead of L2
</commit_message>
<xml_diff>
--- a/Docs/Deep Learning Capstone Presentation.pptx
+++ b/Docs/Deep Learning Capstone Presentation.pptx
@@ -1059,7 +1059,7 @@
                 </a:solidFill>
                 <a:latin typeface="IBM Plex Sans"/>
               </a:rPr>
-              <a:t>52.94%</a:t>
+              <a:t>54.08%</a:t>
             </a:r>
           </a:p>
         </p:txBody>
@@ -1174,7 +1174,7 @@
                 </a:solidFill>
                 <a:latin typeface="IBM Plex Sans"/>
               </a:rPr>
-              <a:t>58.36%</a:t>
+              <a:t>59.12%</a:t>
             </a:r>
           </a:p>
         </p:txBody>
@@ -2043,7 +2043,7 @@
                 </a:solidFill>
                 <a:latin typeface="IBM Plex Sans"/>
               </a:rPr>
-              <a:t>16 -&gt; 49.78%</a:t>
+              <a:t>16 -&gt; 50.58%</a:t>
             </a:r>
           </a:p>
         </p:txBody>
@@ -2078,7 +2078,7 @@
                 </a:solidFill>
                 <a:latin typeface="IBM Plex Sans"/>
               </a:rPr>
-              <a:t>32 -&gt; 50.46%</a:t>
+              <a:t>32 -&gt; 50.92%</a:t>
             </a:r>
           </a:p>
         </p:txBody>
@@ -2113,7 +2113,7 @@
                 </a:solidFill>
                 <a:latin typeface="IBM Plex Sans"/>
               </a:rPr>
-              <a:t>64 -&gt; 51.82%</a:t>
+              <a:t>64 -&gt; 52.04%</a:t>
             </a:r>
           </a:p>
         </p:txBody>
@@ -2148,7 +2148,7 @@
                 </a:solidFill>
                 <a:latin typeface="IBM Plex Sans"/>
               </a:rPr>
-              <a:t>128 -&gt; 52.14%</a:t>
+              <a:t>128 -&gt; 52.52%</a:t>
             </a:r>
           </a:p>
         </p:txBody>
@@ -2723,7 +2723,7 @@
                 </a:solidFill>
                 <a:latin typeface="IBM Plex Sans"/>
               </a:rPr>
-              <a:t>52.56% against 50.30%</a:t>
+              <a:t>52.78% against 49.28%</a:t>
             </a:r>
           </a:p>
           <a:p>
@@ -2752,7 +2752,7 @@
                 </a:solidFill>
                 <a:latin typeface="IBM Plex Sans"/>
               </a:rPr>
-              <a:t>Min val loss 1.3957</a:t>
+              <a:t>Min val loss 1.3932</a:t>
             </a:r>
           </a:p>
           <a:p>
@@ -2768,7 +2768,7 @@
                 </a:solidFill>
                 <a:latin typeface="IBM Plex Sans"/>
               </a:rPr>
-              <a:t>against 1.4592</a:t>
+              <a:t>against 1.4807</a:t>
             </a:r>
           </a:p>
           <a:p>
@@ -2797,7 +2797,7 @@
                 </a:solidFill>
                 <a:latin typeface="IBM Plex Sans"/>
               </a:rPr>
-              <a:t>Peaks at epoch 29;</a:t>
+              <a:t>Peaks at epoch 31;</a:t>
             </a:r>
           </a:p>
           <a:p>
@@ -2829,7 +2829,7 @@
                 </a:solidFill>
                 <a:latin typeface="IBM Plex Sans"/>
               </a:rPr>
-              <a:t>at epoch 49</a:t>
+              <a:t>at epoch 50</a:t>
             </a:r>
           </a:p>
         </p:txBody>
@@ -3404,7 +3404,7 @@
                 </a:solidFill>
                 <a:latin typeface="IBM Plex Sans"/>
               </a:rPr>
-              <a:t>52.42% accuracy</a:t>
+              <a:t>54.16% accuracy</a:t>
             </a:r>
           </a:p>
           <a:p>
@@ -3433,7 +3433,7 @@
                 </a:solidFill>
                 <a:latin typeface="IBM Plex Sans"/>
               </a:rPr>
-              <a:t>Gap 29.96%  -&gt;  6.17%</a:t>
+              <a:t>Gap 32.11%  -&gt;  4.47%</a:t>
             </a:r>
           </a:p>
           <a:p>
@@ -3462,7 +3462,7 @@
                 </a:solidFill>
                 <a:latin typeface="IBM Plex Sans"/>
               </a:rPr>
-              <a:t>Val loss 1.3328,</a:t>
+              <a:t>Val loss 1.3022,</a:t>
             </a:r>
           </a:p>
           <a:p>
@@ -3507,7 +3507,7 @@
                 </a:solidFill>
                 <a:latin typeface="IBM Plex Sans"/>
               </a:rPr>
-              <a:t>Early Stopping 51.96%</a:t>
+              <a:t>Early Stopping 51.72%</a:t>
             </a:r>
           </a:p>
           <a:p>
@@ -3523,7 +3523,7 @@
                 </a:solidFill>
                 <a:latin typeface="IBM Plex Sans"/>
               </a:rPr>
-              <a:t>L2 51.82%</a:t>
+              <a:t>L2 52.30%</a:t>
             </a:r>
           </a:p>
         </p:txBody>
@@ -4098,7 +4098,7 @@
                 </a:solidFill>
                 <a:latin typeface="IBM Plex Sans"/>
               </a:rPr>
-              <a:t>Train 99.13%</a:t>
+              <a:t>Train 99.20%</a:t>
             </a:r>
           </a:p>
           <a:p>
@@ -4114,7 +4114,7 @@
                 </a:solidFill>
                 <a:latin typeface="IBM Plex Sans"/>
               </a:rPr>
-              <a:t>Validation 44.88%</a:t>
+              <a:t>Validation 40.70%</a:t>
             </a:r>
           </a:p>
           <a:p>
@@ -4143,7 +4143,7 @@
                 </a:solidFill>
                 <a:latin typeface="IBM Plex Sans"/>
               </a:rPr>
-              <a:t>Gap 54.25%</a:t>
+              <a:t>Gap 58.50%</a:t>
             </a:r>
           </a:p>
           <a:p>
@@ -4172,7 +4172,7 @@
                 </a:solidFill>
                 <a:latin typeface="IBM Plex Sans"/>
               </a:rPr>
-              <a:t>Final val loss 3.8244</a:t>
+              <a:t>Final val loss 4.4448</a:t>
             </a:r>
           </a:p>
           <a:p>
@@ -4217,7 +4217,7 @@
                 </a:solidFill>
                 <a:latin typeface="IBM Plex Sans"/>
               </a:rPr>
-              <a:t>from 53.00% to 44.88%</a:t>
+              <a:t>from 53.18% to 44.64%</a:t>
             </a:r>
           </a:p>
         </p:txBody>
@@ -4682,7 +4682,7 @@
                 </a:solidFill>
                 <a:latin typeface="IBM Plex Sans"/>
               </a:rPr>
-              <a:t>L2 helps the ending</a:t>
+              <a:t>Dropout does the work</a:t>
             </a:r>
           </a:p>
         </p:txBody>
@@ -4721,7 +4721,7 @@
                 </a:solidFill>
                 <a:latin typeface="IBM Plex Sans"/>
               </a:rPr>
-              <a:t>Final validation accuracy 51.92% against 50.60%</a:t>
+              <a:t>Final validation accuracy 54.40% against 51.04%</a:t>
             </a:r>
           </a:p>
           <a:p>
@@ -4737,7 +4737,7 @@
                 </a:solidFill>
                 <a:latin typeface="IBM Plex Sans"/>
               </a:rPr>
-              <a:t>Gap 27.72% against 31.95%</a:t>
+              <a:t>Gap 4.74% against 30.76%</a:t>
             </a:r>
           </a:p>
         </p:txBody>
@@ -4864,7 +4864,7 @@
                 </a:solidFill>
                 <a:latin typeface="IBM Plex Sans"/>
               </a:rPr>
-              <a:t>But not the peak</a:t>
+              <a:t>And the peak as well</a:t>
             </a:r>
           </a:p>
         </p:txBody>
@@ -4903,7 +4903,7 @@
                 </a:solidFill>
                 <a:latin typeface="IBM Plex Sans"/>
               </a:rPr>
-              <a:t>Best validation accuracy 52.92% with L2,</a:t>
+              <a:t>Best validation accuracy 54.62% with Dropout,</a:t>
             </a:r>
           </a:p>
           <a:p>
@@ -4919,7 +4919,7 @@
                 </a:solidFill>
                 <a:latin typeface="IBM Plex Sans"/>
               </a:rPr>
-              <a:t>52.94% without: one image out of 5,000</a:t>
+              <a:t>52.84% without: 89 images out of 5,000</a:t>
             </a:r>
           </a:p>
         </p:txBody>
@@ -5046,7 +5046,7 @@
                 </a:solidFill>
                 <a:latin typeface="IBM Plex Sans"/>
               </a:rPr>
-              <a:t>L2 limits how far the model overfits by epoch 50. It does not raise the best result the model reaches.</a:t>
+              <a:t>Dropout raises the peak and closes the gap at the same time. It is the regularizer carried into the final model.</a:t>
             </a:r>
           </a:p>
         </p:txBody>
@@ -5186,7 +5186,7 @@
                 </a:solidFill>
                 <a:latin typeface="IBM Plex Sans"/>
               </a:rPr>
-              <a:t>3 x 512, Adam 0.0001, batch 128, L2 0.0001, Early Stopping</a:t>
+              <a:t>3 x 512, Adam 0.0001, batch 128, Dropout 0.3, Early Stopping</a:t>
             </a:r>
           </a:p>
         </p:txBody>
@@ -5423,7 +5423,7 @@
                 </a:solidFill>
                 <a:latin typeface="IBM Plex Sans"/>
               </a:rPr>
-              <a:t>automobile  0.64      frog  0.58</a:t>
+              <a:t>ship  0.66            frog  0.59</a:t>
             </a:r>
           </a:p>
           <a:p>
@@ -5439,7 +5439,7 @@
                 </a:solidFill>
                 <a:latin typeface="IBM Plex Sans"/>
               </a:rPr>
-              <a:t>ship  0.63           truck  0.58</a:t>
+              <a:t>automobile  0.66     truck  0.59</a:t>
             </a:r>
           </a:p>
           <a:p>
@@ -5455,7 +5455,7 @@
                 </a:solidFill>
                 <a:latin typeface="IBM Plex Sans"/>
               </a:rPr>
-              <a:t>horse  0.59          deer  0.45</a:t>
+              <a:t>airplane  0.61       deer  0.47</a:t>
             </a:r>
           </a:p>
           <a:p>
@@ -5471,7 +5471,7 @@
                 </a:solidFill>
                 <a:latin typeface="IBM Plex Sans"/>
               </a:rPr>
-              <a:t>airplane  0.59      bird  0.43</a:t>
+              <a:t>horse  0.60         dog  0.43</a:t>
             </a:r>
           </a:p>
           <a:p>
@@ -5487,7 +5487,7 @@
                 </a:solidFill>
                 <a:latin typeface="IBM Plex Sans"/>
               </a:rPr>
-              <a:t>                              dog  0.41</a:t>
+              <a:t>                              bird  0.43</a:t>
             </a:r>
           </a:p>
           <a:p>
@@ -5630,7 +5630,7 @@
                 </a:solidFill>
                 <a:latin typeface="IBM Plex Sans"/>
               </a:rPr>
-              <a:t>52.94%</a:t>
+              <a:t>54.08%</a:t>
             </a:r>
           </a:p>
         </p:txBody>
@@ -5792,7 +5792,7 @@
                 </a:solidFill>
                 <a:latin typeface="IBM Plex Sans"/>
               </a:rPr>
-              <a:t>52.43%</a:t>
+              <a:t>53.99%</a:t>
             </a:r>
           </a:p>
         </p:txBody>
@@ -5954,7 +5954,7 @@
                 </a:solidFill>
                 <a:latin typeface="IBM Plex Sans"/>
               </a:rPr>
-              <a:t>1.4837</a:t>
+              <a:t>1.2815</a:t>
             </a:r>
           </a:p>
         </p:txBody>
@@ -6655,7 +6655,7 @@
                 </a:solidFill>
                 <a:latin typeface="IBM Plex Sans"/>
               </a:rPr>
-              <a:t>cat  35.52% F1</a:t>
+              <a:t>cat  35.96% F1</a:t>
             </a:r>
           </a:p>
           <a:p>
@@ -6671,7 +6671,7 @@
                 </a:solidFill>
                 <a:latin typeface="IBM Plex Sans"/>
               </a:rPr>
-              <a:t>dog  40.93%</a:t>
+              <a:t>bird  42.51%</a:t>
             </a:r>
           </a:p>
           <a:p>
@@ -6687,7 +6687,7 @@
                 </a:solidFill>
                 <a:latin typeface="IBM Plex Sans"/>
               </a:rPr>
-              <a:t>bird  43.08%</a:t>
+              <a:t>dog  42.82%</a:t>
             </a:r>
           </a:p>
         </p:txBody>
@@ -6853,7 +6853,7 @@
                 </a:solidFill>
                 <a:latin typeface="IBM Plex Sans"/>
               </a:rPr>
-              <a:t>automobile  64.24% F1</a:t>
+              <a:t>ship  66.08% F1</a:t>
             </a:r>
           </a:p>
           <a:p>
@@ -6869,7 +6869,7 @@
                 </a:solidFill>
                 <a:latin typeface="IBM Plex Sans"/>
               </a:rPr>
-              <a:t>ship  62.74%</a:t>
+              <a:t>automobile  65.58%</a:t>
             </a:r>
           </a:p>
           <a:p>
@@ -6885,7 +6885,7 @@
                 </a:solidFill>
                 <a:latin typeface="IBM Plex Sans"/>
               </a:rPr>
-              <a:t>horse  59.03%</a:t>
+              <a:t>airplane  61.38%</a:t>
             </a:r>
           </a:p>
         </p:txBody>
@@ -7012,7 +7012,7 @@
                 </a:solidFill>
                 <a:latin typeface="IBM Plex Sans"/>
               </a:rPr>
-              <a:t>Cat and dog account for 350 errors between them, the largest confusion pair in the matrix.</a:t>
+              <a:t>Cat and dog account for 383 errors between them, the largest confusion pair in the matrix.</a:t>
             </a:r>
           </a:p>
         </p:txBody>
@@ -7476,7 +7476,7 @@
                 </a:solidFill>
                 <a:latin typeface="IBM Plex Sans"/>
               </a:rPr>
-              <a:t>53.10%,  gap 0.4414</a:t>
+              <a:t>52.84%,  gap 0.4085</a:t>
             </a:r>
           </a:p>
           <a:p>
@@ -7521,7 +7521,7 @@
                 </a:solidFill>
                 <a:latin typeface="IBM Plex Sans"/>
               </a:rPr>
-              <a:t>55.36%,  gap 0.3822</a:t>
+              <a:t>54.92%,  gap 0.3631</a:t>
             </a:r>
           </a:p>
           <a:p>
@@ -7566,7 +7566,7 @@
                 </a:solidFill>
                 <a:latin typeface="IBM Plex Sans"/>
               </a:rPr>
-              <a:t>58.36%,  gap 0.0932</a:t>
+              <a:t>59.12%,  gap 0.0791</a:t>
             </a:r>
           </a:p>
         </p:txBody>
@@ -7693,7 +7693,7 @@
                 </a:solidFill>
                 <a:latin typeface="IBM Plex Sans"/>
               </a:rPr>
-              <a:t>+5.26 points and the gap nearly closed. The strongest single result in the project, and it cost no parameters.</a:t>
+              <a:t>+6.28 points and the gap nearly closed. The strongest single result in the project, and it cost no parameters.</a:t>
             </a:r>
           </a:p>
         </p:txBody>
@@ -8621,7 +8621,7 @@
                 </a:solidFill>
                 <a:latin typeface="IBM Plex Sans"/>
               </a:rPr>
-              <a:t>Dropout closed the gap 30% to 6%</a:t>
+              <a:t>Dropout closed the gap 32% to 4%</a:t>
             </a:r>
           </a:p>
         </p:txBody>
@@ -8818,7 +8818,7 @@
                 </a:solidFill>
                 <a:latin typeface="IBM Plex Sans"/>
               </a:rPr>
-              <a:t>99.13% train, 44.88% validation</a:t>
+              <a:t>99.20% train, 40.70% validation</a:t>
             </a:r>
           </a:p>
         </p:txBody>
@@ -9015,7 +9015,7 @@
                 </a:solidFill>
                 <a:latin typeface="IBM Plex Sans"/>
               </a:rPr>
-              <a:t>58.36%, the best score recorded</a:t>
+              <a:t>59.12%, the best score recorded</a:t>
             </a:r>
           </a:p>
         </p:txBody>
@@ -17117,7 +17117,7 @@
                 </a:solidFill>
                 <a:latin typeface="IBM Plex Sans"/>
               </a:rPr>
-              <a:t>0.01  -&gt;  37.02%</a:t>
+              <a:t>0.01  -&gt;  38.64%</a:t>
             </a:r>
           </a:p>
         </p:txBody>
@@ -17152,7 +17152,7 @@
                 </a:solidFill>
                 <a:latin typeface="IBM Plex Sans"/>
               </a:rPr>
-              <a:t>0.001  -&gt;  47.52%</a:t>
+              <a:t>0.001  -&gt;  47.68%</a:t>
             </a:r>
           </a:p>
         </p:txBody>
@@ -17187,7 +17187,7 @@
                 </a:solidFill>
                 <a:latin typeface="IBM Plex Sans"/>
               </a:rPr>
-              <a:t>0.0001  -&gt;  53.16%</a:t>
+              <a:t>0.0001  -&gt;  52.64%</a:t>
             </a:r>
           </a:p>
         </p:txBody>
@@ -17314,7 +17314,7 @@
                 </a:solidFill>
                 <a:latin typeface="IBM Plex Sans"/>
               </a:rPr>
-              <a:t>0.0001 wins on both accuracy and loss. At 0.001 the model peaks by epoch 12 then diverges to a loss of 3.13.</a:t>
+              <a:t>0.0001 wins on both accuracy and loss. At 0.001 the model peaks by epoch 12 then diverges to a loss of 2.87.</a:t>
             </a:r>
           </a:p>
         </p:txBody>

</xml_diff>

<commit_message>
added more plots to the web demo
</commit_message>
<xml_diff>
--- a/Docs/Deep Learning Capstone Presentation.pptx
+++ b/Docs/Deep Learning Capstone Presentation.pptx
@@ -1419,7 +1419,7 @@
         <p:spPr>
           <a:xfrm>
             <a:off x="859536" y="1042415"/>
-            <a:ext cx="10789920" cy="329184"/>
+            <a:ext cx="10789920" cy="496824"/>
           </a:xfrm>
           <a:prstGeom prst="rect">
             <a:avLst/>
@@ -1441,6 +1441,18 @@
                 <a:latin typeface="IBM Plex Sans"/>
               </a:rPr>
               <a:t>16 / 32 / 64 / 128 at the selected learning rate</a:t>
+            </a:r>
+          </a:p>
+          <a:p>
+            <a:pPr algn="l"/>
+            <a:r>
+              <a:rPr sz="1100" b="0">
+                <a:solidFill>
+                  <a:srgbClr val="9B78F7"/>
+                </a:solidFill>
+                <a:latin typeface="IBM Plex Sans"/>
+              </a:rPr>
+              <a:t>Varied: batch size 16 / 32 / 64 / 128 · Fixed: 3 x 512 ReLU, Adam 0.0001, 50 epochs</a:t>
             </a:r>
           </a:p>
         </p:txBody>
@@ -2394,7 +2406,7 @@
         <p:spPr>
           <a:xfrm>
             <a:off x="859536" y="1042415"/>
-            <a:ext cx="10789920" cy="329184"/>
+            <a:ext cx="10789920" cy="496824"/>
           </a:xfrm>
           <a:prstGeom prst="rect">
             <a:avLst/>
@@ -2416,6 +2428,18 @@
                 <a:latin typeface="IBM Plex Sans"/>
               </a:rPr>
               <a:t>Adam at 0.0001 against SGD at 0.01</a:t>
+            </a:r>
+          </a:p>
+          <a:p>
+            <a:pPr algn="l"/>
+            <a:r>
+              <a:rPr sz="1100" b="0">
+                <a:solidFill>
+                  <a:srgbClr val="9B78F7"/>
+                </a:solidFill>
+                <a:latin typeface="IBM Plex Sans"/>
+              </a:rPr>
+              <a:t>Varied: Adam 0.0001 vs SGD 0.01, no momentum · Fixed: 3 x 512 ReLU, batch 128, 50 epochs</a:t>
             </a:r>
           </a:p>
         </p:txBody>
@@ -3075,7 +3099,7 @@
         <p:spPr>
           <a:xfrm>
             <a:off x="859536" y="1042415"/>
-            <a:ext cx="10789920" cy="329184"/>
+            <a:ext cx="10789920" cy="496824"/>
           </a:xfrm>
           <a:prstGeom prst="rect">
             <a:avLst/>
@@ -3097,6 +3121,18 @@
                 <a:latin typeface="IBM Plex Sans"/>
               </a:rPr>
               <a:t>Dropout 0.3, Early Stopping and L2 against an unregularized baseline</a:t>
+            </a:r>
+          </a:p>
+          <a:p>
+            <a:pPr algn="l"/>
+            <a:r>
+              <a:rPr sz="1100" b="0">
+                <a:solidFill>
+                  <a:srgbClr val="9B78F7"/>
+                </a:solidFill>
+                <a:latin typeface="IBM Plex Sans"/>
+              </a:rPr>
+              <a:t>Varied: none / Dropout 0.3 / EarlyStopping val_loss patience 5 / L2 0.0001 · Fixed: 3 x 512 ReLU, Adam 0.0001, batch 128, 50 epochs</a:t>
             </a:r>
           </a:p>
         </p:txBody>
@@ -3769,7 +3805,7 @@
         <p:spPr>
           <a:xfrm>
             <a:off x="859536" y="1042415"/>
-            <a:ext cx="10789920" cy="329184"/>
+            <a:ext cx="10789920" cy="496824"/>
           </a:xfrm>
           <a:prstGeom prst="rect">
             <a:avLst/>
@@ -3791,6 +3827,18 @@
                 <a:latin typeface="IBM Plex Sans"/>
               </a:rPr>
               <a:t>The same network, with and without BatchNorm after each Dense layer</a:t>
+            </a:r>
+          </a:p>
+          <a:p>
+            <a:pPr algn="l"/>
+            <a:r>
+              <a:rPr sz="1100" b="0">
+                <a:solidFill>
+                  <a:srgbClr val="9B78F7"/>
+                </a:solidFill>
+                <a:latin typeface="IBM Plex Sans"/>
+              </a:rPr>
+              <a:t>Varied: BatchNorm between Dense and ReLU · Fixed: 3 x 512, Adam 0.0001, batch 128, 50 epochs, no Dropout</a:t>
             </a:r>
           </a:p>
         </p:txBody>
@@ -4463,7 +4511,7 @@
         <p:spPr>
           <a:xfrm>
             <a:off x="859536" y="1042415"/>
-            <a:ext cx="10789920" cy="329184"/>
+            <a:ext cx="10789920" cy="496824"/>
           </a:xfrm>
           <a:prstGeom prst="rect">
             <a:avLst/>
@@ -4485,6 +4533,18 @@
                 <a:latin typeface="IBM Plex Sans"/>
               </a:rPr>
               <a:t>One variable removed, everything else identical</a:t>
+            </a:r>
+          </a:p>
+          <a:p>
+            <a:pPr algn="l"/>
+            <a:r>
+              <a:rPr sz="1100" b="0">
+                <a:solidFill>
+                  <a:srgbClr val="9B78F7"/>
+                </a:solidFill>
+                <a:latin typeface="IBM Plex Sans"/>
+              </a:rPr>
+              <a:t>Varied: Dropout 0.3 present or absent · Fixed: 3 x 512 ReLU, Adam 0.0001, batch 128, 50 epochs, seed 42</a:t>
             </a:r>
           </a:p>
         </p:txBody>
@@ -5165,7 +5225,7 @@
         <p:spPr>
           <a:xfrm>
             <a:off x="859536" y="1042415"/>
-            <a:ext cx="10789920" cy="329184"/>
+            <a:ext cx="10789920" cy="496824"/>
           </a:xfrm>
           <a:prstGeom prst="rect">
             <a:avLst/>
@@ -5187,6 +5247,18 @@
                 <a:latin typeface="IBM Plex Sans"/>
               </a:rPr>
               <a:t>3 x 512, Adam 0.0001, batch 128, Dropout 0.3, Early Stopping</a:t>
+            </a:r>
+          </a:p>
+          <a:p>
+            <a:pPr algn="l"/>
+            <a:r>
+              <a:rPr sz="1100" b="0">
+                <a:solidFill>
+                  <a:srgbClr val="9B78F7"/>
+                </a:solidFill>
+                <a:latin typeface="IBM Plex Sans"/>
+              </a:rPr>
+              <a:t>3 x 512 ReLU · Dropout 0.3 · Adam 0.0001 · batch 128 · max 50 epochs, EarlyStopping val_loss patience 5, restore best · seed 42</a:t>
             </a:r>
           </a:p>
         </p:txBody>
@@ -6397,7 +6469,7 @@
         <p:spPr>
           <a:xfrm>
             <a:off x="859536" y="1042415"/>
-            <a:ext cx="10789920" cy="329184"/>
+            <a:ext cx="10789920" cy="496824"/>
           </a:xfrm>
           <a:prstGeom prst="rect">
             <a:avLst/>
@@ -6419,6 +6491,18 @@
                 <a:latin typeface="IBM Plex Sans"/>
               </a:rPr>
               <a:t>The mistakes are concentrated between visually similar classes</a:t>
+            </a:r>
+          </a:p>
+          <a:p>
+            <a:pPr algn="l"/>
+            <a:r>
+              <a:rPr sz="1100" b="0">
+                <a:solidFill>
+                  <a:srgbClr val="9B78F7"/>
+                </a:solidFill>
+                <a:latin typeface="IBM Plex Sans"/>
+              </a:rPr>
+              <a:t>Final model: 3 x 512 ReLU · Dropout 0.3 · Adam 0.0001 · batch 128 · EarlyStopping, best weights restored · seed 42</a:t>
             </a:r>
           </a:p>
         </p:txBody>
@@ -7131,7 +7215,7 @@
         <p:spPr>
           <a:xfrm>
             <a:off x="859536" y="1042415"/>
-            <a:ext cx="10789920" cy="329184"/>
+            <a:ext cx="10789920" cy="496824"/>
           </a:xfrm>
           <a:prstGeom prst="rect">
             <a:avLst/>
@@ -7153,6 +7237,18 @@
                 <a:latin typeface="IBM Plex Sans"/>
               </a:rPr>
               <a:t>Random flip and shift, applied before the image is flattened</a:t>
+            </a:r>
+          </a:p>
+          <a:p>
+            <a:pPr algn="l"/>
+            <a:r>
+              <a:rPr sz="1100" b="0">
+                <a:solidFill>
+                  <a:srgbClr val="9B78F7"/>
+                </a:solidFill>
+                <a:latin typeface="IBM Plex Sans"/>
+              </a:rPr>
+              <a:t>Varied: none / RandomFlip horizontal / + RandomTranslation 0.1 · Fixed: 3 x 512 ReLU, Adam 0.0001, batch 128, 100 epochs, seed 42</a:t>
             </a:r>
           </a:p>
         </p:txBody>
@@ -13457,7 +13553,7 @@
         <p:spPr>
           <a:xfrm>
             <a:off x="859536" y="1042415"/>
-            <a:ext cx="10789920" cy="329184"/>
+            <a:ext cx="10789920" cy="496824"/>
           </a:xfrm>
           <a:prstGeom prst="rect">
             <a:avLst/>
@@ -13479,6 +13575,18 @@
                 <a:latin typeface="IBM Plex Sans"/>
               </a:rPr>
               <a:t>One hidden layer, 512 units, Adam at 0.0001, batch 128</a:t>
+            </a:r>
+          </a:p>
+          <a:p>
+            <a:pPr algn="l"/>
+            <a:r>
+              <a:rPr sz="1100" b="0">
+                <a:solidFill>
+                  <a:srgbClr val="9B78F7"/>
+                </a:solidFill>
+                <a:latin typeface="IBM Plex Sans"/>
+              </a:rPr>
+              <a:t>1 x 512 ReLU · Adam 0.0001 · batch 128 · 50 epochs · sparse categorical cross-entropy · seed 42</a:t>
             </a:r>
           </a:p>
         </p:txBody>
@@ -14119,7 +14227,7 @@
         <p:spPr>
           <a:xfrm>
             <a:off x="859536" y="1042415"/>
-            <a:ext cx="10789920" cy="329184"/>
+            <a:ext cx="10789920" cy="496824"/>
           </a:xfrm>
           <a:prstGeom prst="rect">
             <a:avLst/>
@@ -14141,6 +14249,18 @@
                 <a:latin typeface="IBM Plex Sans"/>
               </a:rPr>
               <a:t>Same data, same seed, same hyperparameters, only depth changes</a:t>
+            </a:r>
+          </a:p>
+          <a:p>
+            <a:pPr algn="l"/>
+            <a:r>
+              <a:rPr sz="1100" b="0">
+                <a:solidFill>
+                  <a:srgbClr val="9B78F7"/>
+                </a:solidFill>
+                <a:latin typeface="IBM Plex Sans"/>
+              </a:rPr>
+              <a:t>Shallow 1 x 512 · Medium 3 x 512 · Deep 5 x 512 · all: ReLU, Adam 0.0001, batch 128, 50 epochs, no regularization, seed 42</a:t>
             </a:r>
           </a:p>
         </p:txBody>
@@ -15085,7 +15205,7 @@
         <p:spPr>
           <a:xfrm>
             <a:off x="859536" y="1042415"/>
-            <a:ext cx="10789920" cy="329184"/>
+            <a:ext cx="10789920" cy="496824"/>
           </a:xfrm>
           <a:prstGeom prst="rect">
             <a:avLst/>
@@ -15107,6 +15227,18 @@
                 <a:latin typeface="IBM Plex Sans"/>
               </a:rPr>
               <a:t>All three land within 38 images of each other</a:t>
+            </a:r>
+          </a:p>
+          <a:p>
+            <a:pPr algn="l"/>
+            <a:r>
+              <a:rPr sz="1100" b="0">
+                <a:solidFill>
+                  <a:srgbClr val="9B78F7"/>
+                </a:solidFill>
+                <a:latin typeface="IBM Plex Sans"/>
+              </a:rPr>
+              <a:t>Shallow 1 x 512 · Medium 3 x 512 · Deep 5 x 512 · all: ReLU, Adam 0.0001, batch 128, 50 epochs, no regularization, seed 42</a:t>
             </a:r>
           </a:p>
         </p:txBody>
@@ -15909,7 +16041,7 @@
         <p:spPr>
           <a:xfrm>
             <a:off x="859536" y="1042415"/>
-            <a:ext cx="10789920" cy="329184"/>
+            <a:ext cx="10789920" cy="496824"/>
           </a:xfrm>
           <a:prstGeom prst="rect">
             <a:avLst/>
@@ -15931,6 +16063,18 @@
                 <a:latin typeface="IBM Plex Sans"/>
               </a:rPr>
               <a:t>Medium, 3 x 512, 2,103,818 parameters</a:t>
+            </a:r>
+          </a:p>
+          <a:p>
+            <a:pPr algn="l"/>
+            <a:r>
+              <a:rPr sz="1100" b="0">
+                <a:solidFill>
+                  <a:srgbClr val="9B78F7"/>
+                </a:solidFill>
+                <a:latin typeface="IBM Plex Sans"/>
+              </a:rPr>
+              <a:t>3 x 512 ReLU · Adam 0.0001 · batch 128 · 50 epochs · no regularization · seed 42</a:t>
             </a:r>
           </a:p>
         </p:txBody>
@@ -16635,7 +16779,7 @@
         <p:spPr>
           <a:xfrm>
             <a:off x="859536" y="1042415"/>
-            <a:ext cx="10789920" cy="329184"/>
+            <a:ext cx="10789920" cy="496824"/>
           </a:xfrm>
           <a:prstGeom prst="rect">
             <a:avLst/>
@@ -16657,6 +16801,18 @@
                 <a:latin typeface="IBM Plex Sans"/>
               </a:rPr>
               <a:t>0.01 / 0.001 / 0.0001, everything else held fixed</a:t>
+            </a:r>
+          </a:p>
+          <a:p>
+            <a:pPr algn="l"/>
+            <a:r>
+              <a:rPr sz="1100" b="0">
+                <a:solidFill>
+                  <a:srgbClr val="9B78F7"/>
+                </a:solidFill>
+                <a:latin typeface="IBM Plex Sans"/>
+              </a:rPr>
+              <a:t>Varied: learning rate 0.01 / 0.001 / 0.0001 · Fixed: 3 x 512 ReLU, Adam, batch 128, 50 epochs</a:t>
             </a:r>
           </a:p>
         </p:txBody>

</xml_diff>